<commit_message>
Ampliar el quiz de las sesiones 2 a 7 de Formación Ajedrez
Cada sesión recibe entre 4 y 6 preguntas nuevas, ancladas en sus propios
«temas» (conducta y dispositivos electrónicos, ritmos y desempates,
sistema suizo y round robin, uso del reloj, logística y comunicación de
decisiones, y el simulacro de arbitraje), sin repetir lo que su quiz ya
preguntaba. Regenerado con herramientas/curso-generar-formacion.py,
academia-cabecera.py y datos-estructurados.py; verificado con
herramientas/verificar-formacion.js.

Co-Authored-By: Claude Sonnet 5 <noreply@anthropic.com>
Claude-Session: https://claude.ai/code/session_01JaQt9vJhVtnfamvjJU7GEu
</commit_message>
<xml_diff>
--- a/cursos/recursos/formacion-ajedrez/02-reglas-de-competicion.pptx
+++ b/cursos/recursos/formacion-ajedrez/02-reglas-de-competicion.pptx
@@ -7959,7 +7959,7 @@
               </a:spcAft>
             </a:pPr>
             <a:r>
-              <a:rPr sz="1400">
+              <a:rPr sz="1200">
                 <a:solidFill>
                   <a:srgbClr val="334E68"/>
                 </a:solidFill>
@@ -7975,7 +7975,7 @@
               </a:spcAft>
             </a:pPr>
             <a:r>
-              <a:rPr sz="1400">
+              <a:rPr sz="1200">
                 <a:solidFill>
                   <a:srgbClr val="334E68"/>
                 </a:solidFill>
@@ -7991,7 +7991,7 @@
               </a:spcAft>
             </a:pPr>
             <a:r>
-              <a:rPr sz="1400">
+              <a:rPr sz="1200">
                 <a:solidFill>
                   <a:srgbClr val="334E68"/>
                 </a:solidFill>
@@ -8007,7 +8007,7 @@
               </a:spcAft>
             </a:pPr>
             <a:r>
-              <a:rPr sz="1400">
+              <a:rPr sz="1200">
                 <a:solidFill>
                   <a:srgbClr val="334E68"/>
                 </a:solidFill>
@@ -8023,7 +8023,7 @@
               </a:spcAft>
             </a:pPr>
             <a:r>
-              <a:rPr sz="1400">
+              <a:rPr sz="1200">
                 <a:solidFill>
                   <a:srgbClr val="334E68"/>
                 </a:solidFill>
@@ -8039,13 +8039,93 @@
               </a:spcAft>
             </a:pPr>
             <a:r>
-              <a:rPr sz="1400">
+              <a:rPr sz="1200">
                 <a:solidFill>
                   <a:srgbClr val="334E68"/>
                 </a:solidFill>
                 <a:latin typeface="Calibri"/>
               </a:rPr>
               <a:t>6. ¿Cuál es la primera sanción de la lista del art. 12.9?</a:t>
+            </a:r>
+          </a:p>
+          <a:p>
+            <a:pPr>
+              <a:spcAft>
+                <a:spcPts val="600"/>
+              </a:spcAft>
+            </a:pPr>
+            <a:r>
+              <a:rPr sz="1200">
+                <a:solidFill>
+                  <a:srgbClr val="334E68"/>
+                </a:solidFill>
+                <a:latin typeface="Calibri"/>
+              </a:rPr>
+              <a:t>7. Para salir de la sala de juego durante la ronda, ¿qué necesita un jugador?</a:t>
+            </a:r>
+          </a:p>
+          <a:p>
+            <a:pPr>
+              <a:spcAft>
+                <a:spcPts val="600"/>
+              </a:spcAft>
+            </a:pPr>
+            <a:r>
+              <a:rPr sz="1200">
+                <a:solidFill>
+                  <a:srgbClr val="334E68"/>
+                </a:solidFill>
+                <a:latin typeface="Calibri"/>
+              </a:rPr>
+              <a:t>8. ¿Puede un jugador que ya terminó su partida quedarse analizándola en un tablero de la sala, junto a mesas que siguen jugando?</a:t>
+            </a:r>
+          </a:p>
+          <a:p>
+            <a:pPr>
+              <a:spcAft>
+                <a:spcPts val="600"/>
+              </a:spcAft>
+            </a:pPr>
+            <a:r>
+              <a:rPr sz="1200">
+                <a:solidFill>
+                  <a:srgbClr val="334E68"/>
+                </a:solidFill>
+                <a:latin typeface="Calibri"/>
+              </a:rPr>
+              <a:t>9. Si no se puede reconstruir la posición anterior a una jugada ilegal, ¿desde dónde continúa la partida?</a:t>
+            </a:r>
+          </a:p>
+          <a:p>
+            <a:pPr>
+              <a:spcAft>
+                <a:spcPts val="600"/>
+              </a:spcAft>
+            </a:pPr>
+            <a:r>
+              <a:rPr sz="1200">
+                <a:solidFill>
+                  <a:srgbClr val="334E68"/>
+                </a:solidFill>
+                <a:latin typeface="Calibri"/>
+              </a:rPr>
+              <a:t>10. ¿Cuál es la sanción más severa de la lista del art. 12.9?</a:t>
+            </a:r>
+          </a:p>
+          <a:p>
+            <a:pPr>
+              <a:spcAft>
+                <a:spcPts val="600"/>
+              </a:spcAft>
+            </a:pPr>
+            <a:r>
+              <a:rPr sz="1200">
+                <a:solidFill>
+                  <a:srgbClr val="334E68"/>
+                </a:solidFill>
+                <a:latin typeface="Calibri"/>
+              </a:rPr>
+              <a:t>11. Un jugador toca una pieza con intención de capturarla. Si luego quiere reclamar que el rival incumplió la regla de pieza tocada, ¿puede hacerlo?</a:t>
             </a:r>
           </a:p>
         </p:txBody>

</xml_diff>

<commit_message>
Ampliar el quiz de las sesiones 2 a 7 de Formación Ajedrez (#785)
Cada sesión recibe entre 4 y 6 preguntas nuevas, ancladas en sus propios
«temas» (conducta y dispositivos electrónicos, ritmos y desempates,
sistema suizo y round robin, uso del reloj, logística y comunicación de
decisiones, y el simulacro de arbitraje), sin repetir lo que su quiz ya
preguntaba. Regenerado con herramientas/curso-generar-formacion.py,
academia-cabecera.py y datos-estructurados.py; verificado con
herramientas/verificar-formacion.js.


Claude-Session: https://claude.ai/code/session_01JaQt9vJhVtnfamvjJU7GEu

Co-authored-by: Claude <noreply@anthropic.com>
</commit_message>
<xml_diff>
--- a/cursos/recursos/formacion-ajedrez/02-reglas-de-competicion.pptx
+++ b/cursos/recursos/formacion-ajedrez/02-reglas-de-competicion.pptx
@@ -7959,7 +7959,7 @@
               </a:spcAft>
             </a:pPr>
             <a:r>
-              <a:rPr sz="1400">
+              <a:rPr sz="1200">
                 <a:solidFill>
                   <a:srgbClr val="334E68"/>
                 </a:solidFill>
@@ -7975,7 +7975,7 @@
               </a:spcAft>
             </a:pPr>
             <a:r>
-              <a:rPr sz="1400">
+              <a:rPr sz="1200">
                 <a:solidFill>
                   <a:srgbClr val="334E68"/>
                 </a:solidFill>
@@ -7991,7 +7991,7 @@
               </a:spcAft>
             </a:pPr>
             <a:r>
-              <a:rPr sz="1400">
+              <a:rPr sz="1200">
                 <a:solidFill>
                   <a:srgbClr val="334E68"/>
                 </a:solidFill>
@@ -8007,7 +8007,7 @@
               </a:spcAft>
             </a:pPr>
             <a:r>
-              <a:rPr sz="1400">
+              <a:rPr sz="1200">
                 <a:solidFill>
                   <a:srgbClr val="334E68"/>
                 </a:solidFill>
@@ -8023,7 +8023,7 @@
               </a:spcAft>
             </a:pPr>
             <a:r>
-              <a:rPr sz="1400">
+              <a:rPr sz="1200">
                 <a:solidFill>
                   <a:srgbClr val="334E68"/>
                 </a:solidFill>
@@ -8039,13 +8039,93 @@
               </a:spcAft>
             </a:pPr>
             <a:r>
-              <a:rPr sz="1400">
+              <a:rPr sz="1200">
                 <a:solidFill>
                   <a:srgbClr val="334E68"/>
                 </a:solidFill>
                 <a:latin typeface="Calibri"/>
               </a:rPr>
               <a:t>6. ¿Cuál es la primera sanción de la lista del art. 12.9?</a:t>
+            </a:r>
+          </a:p>
+          <a:p>
+            <a:pPr>
+              <a:spcAft>
+                <a:spcPts val="600"/>
+              </a:spcAft>
+            </a:pPr>
+            <a:r>
+              <a:rPr sz="1200">
+                <a:solidFill>
+                  <a:srgbClr val="334E68"/>
+                </a:solidFill>
+                <a:latin typeface="Calibri"/>
+              </a:rPr>
+              <a:t>7. Para salir de la sala de juego durante la ronda, ¿qué necesita un jugador?</a:t>
+            </a:r>
+          </a:p>
+          <a:p>
+            <a:pPr>
+              <a:spcAft>
+                <a:spcPts val="600"/>
+              </a:spcAft>
+            </a:pPr>
+            <a:r>
+              <a:rPr sz="1200">
+                <a:solidFill>
+                  <a:srgbClr val="334E68"/>
+                </a:solidFill>
+                <a:latin typeface="Calibri"/>
+              </a:rPr>
+              <a:t>8. ¿Puede un jugador que ya terminó su partida quedarse analizándola en un tablero de la sala, junto a mesas que siguen jugando?</a:t>
+            </a:r>
+          </a:p>
+          <a:p>
+            <a:pPr>
+              <a:spcAft>
+                <a:spcPts val="600"/>
+              </a:spcAft>
+            </a:pPr>
+            <a:r>
+              <a:rPr sz="1200">
+                <a:solidFill>
+                  <a:srgbClr val="334E68"/>
+                </a:solidFill>
+                <a:latin typeface="Calibri"/>
+              </a:rPr>
+              <a:t>9. Si no se puede reconstruir la posición anterior a una jugada ilegal, ¿desde dónde continúa la partida?</a:t>
+            </a:r>
+          </a:p>
+          <a:p>
+            <a:pPr>
+              <a:spcAft>
+                <a:spcPts val="600"/>
+              </a:spcAft>
+            </a:pPr>
+            <a:r>
+              <a:rPr sz="1200">
+                <a:solidFill>
+                  <a:srgbClr val="334E68"/>
+                </a:solidFill>
+                <a:latin typeface="Calibri"/>
+              </a:rPr>
+              <a:t>10. ¿Cuál es la sanción más severa de la lista del art. 12.9?</a:t>
+            </a:r>
+          </a:p>
+          <a:p>
+            <a:pPr>
+              <a:spcAft>
+                <a:spcPts val="600"/>
+              </a:spcAft>
+            </a:pPr>
+            <a:r>
+              <a:rPr sz="1200">
+                <a:solidFill>
+                  <a:srgbClr val="334E68"/>
+                </a:solidFill>
+                <a:latin typeface="Calibri"/>
+              </a:rPr>
+              <a:t>11. Un jugador toca una pieza con intención de capturarla. Si luego quiere reclamar que el rival incumplió la regla de pieza tocada, ¿puede hacerlo?</a:t>
             </a:r>
           </a:p>
         </p:txBody>

</xml_diff>